<commit_message>
mise à jour du projet : finale
</commit_message>
<xml_diff>
--- a/docs/Projet-churn.pptx
+++ b/docs/Projet-churn.pptx
@@ -5,7 +5,7 @@
     <p:sldMasterId id="2147483648" r:id="rId1"/>
   </p:sldMasterIdLst>
   <p:notesMasterIdLst>
-    <p:notesMasterId r:id="rId18"/>
+    <p:notesMasterId r:id="rId17"/>
   </p:notesMasterIdLst>
   <p:sldIdLst>
     <p:sldId id="256" r:id="rId2"/>
@@ -22,7 +22,7 @@
     <p:sldId id="267" r:id="rId13"/>
     <p:sldId id="268" r:id="rId14"/>
     <p:sldId id="269" r:id="rId15"/>
-    <p:sldId id="271" r:id="rId17"/>
+    <p:sldId id="271" r:id="rId16"/>
   </p:sldIdLst>
   <p:sldSz cx="9144000" cy="5143500" type="screen16x9"/>
   <p:notesSz cx="5143500" cy="9144000"/>
@@ -773,7 +773,7 @@
 </p:notes>
 </file>
 
-<file path=ppt/notesSlides/notesSlide16.xml><?xml version="1.0" encoding="utf-8"?>
+<file path=ppt/notesSlides/notesSlide15.xml><?xml version="1.0" encoding="utf-8"?>
 <p:notes xmlns:a="http://schemas.openxmlformats.org/drawingml/2006/main" xmlns:r="http://schemas.openxmlformats.org/officeDocument/2006/relationships" xmlns:p="http://schemas.openxmlformats.org/presentationml/2006/main">
   <p:cSld>
     <p:spTree>
@@ -841,7 +841,7 @@
           <a:p>
             <a:fld id="{F7021451-1387-4CA6-816F-3879F97B5CBC}" type="slidenum">
               <a:rPr lang="en-US"/>
-              <a:t>16</a:t>
+              <a:t>15</a:t>
             </a:fld>
             <a:endParaRPr lang="en-US"/>
           </a:p>
@@ -4417,7 +4417,7 @@
         </p:blipFill>
         <p:spPr>
           <a:xfrm>
-            <a:off x="4941278" y="1365035"/>
+            <a:off x="4941278" y="1357778"/>
             <a:ext cx="3985846" cy="2719754"/>
           </a:xfrm>
           <a:prstGeom prst="rect">
@@ -5102,6 +5102,7 @@
           <a:lstStyle/>
           <a:p>
             <a:pPr algn="ctr"/>
+            <a:endParaRPr/>
           </a:p>
         </p:txBody>
       </p:sp>
@@ -5283,7 +5284,7 @@
 </p:sld>
 </file>
 
-<file path=ppt/slides/slide16.xml><?xml version="1.0" encoding="utf-8"?>
+<file path=ppt/slides/slide15.xml><?xml version="1.0" encoding="utf-8"?>
 <p:sld xmlns:a="http://schemas.openxmlformats.org/drawingml/2006/main" xmlns:r="http://schemas.openxmlformats.org/officeDocument/2006/relationships" xmlns:p="http://schemas.openxmlformats.org/presentationml/2006/main">
   <p:cSld name="Slide 16">
     <p:spTree>

</xml_diff>